<commit_message>
Fix MMMU-Pro code block overflow and strengthen layout review
</commit_message>
<xml_diff>
--- a/slides/datasets-in-10-minutes-mmmu-pro.pptx
+++ b/slides/datasets-in-10-minutes-mmmu-pro.pptx
@@ -19986,7 +19986,7 @@
         <p:spPr>
           <a:xfrm>
             <a:off x="548640" y="1508760"/>
-            <a:ext cx="8046720" cy="2049272"/>
+            <a:ext cx="8046720" cy="2222500"/>
           </a:xfrm>
           <a:prstGeom prst="rect">
             <a:avLst/>
@@ -20014,12 +20014,12 @@
           </a:fontRef>
         </p:style>
         <p:txBody>
-          <a:bodyPr rtlCol="0" anchor="ctr" wrap="none" lIns="152400" rIns="152400" tIns="127000" bIns="127000"/>
+          <a:bodyPr rtlCol="0" anchor="t" wrap="none" lIns="152400" rIns="152400" tIns="92710" bIns="127000"/>
           <a:lstStyle/>
           <a:p>
             <a:pPr algn="l">
               <a:lnSpc>
-                <a:spcPct val="114000"/>
+                <a:spcPts val="1937"/>
               </a:lnSpc>
               <a:spcBef>
                 <a:spcPts val="0"/>
@@ -20050,7 +20050,7 @@
           <a:p>
             <a:pPr algn="l">
               <a:lnSpc>
-                <a:spcPct val="114000"/>
+                <a:spcPts val="1937"/>
               </a:lnSpc>
               <a:spcBef>
                 <a:spcPts val="0"/>
@@ -20081,7 +20081,7 @@
           <a:p>
             <a:pPr algn="l">
               <a:lnSpc>
-                <a:spcPct val="114000"/>
+                <a:spcPts val="1937"/>
               </a:lnSpc>
               <a:spcBef>
                 <a:spcPts val="0"/>
@@ -20112,7 +20112,7 @@
           <a:p>
             <a:pPr algn="l">
               <a:lnSpc>
-                <a:spcPct val="114000"/>
+                <a:spcPts val="1937"/>
               </a:lnSpc>
               <a:spcBef>
                 <a:spcPts val="0"/>
@@ -20143,7 +20143,7 @@
           <a:p>
             <a:pPr algn="l">
               <a:lnSpc>
-                <a:spcPct val="114000"/>
+                <a:spcPts val="1937"/>
               </a:lnSpc>
               <a:spcBef>
                 <a:spcPts val="0"/>
@@ -20174,7 +20174,7 @@
           <a:p>
             <a:pPr algn="l">
               <a:lnSpc>
-                <a:spcPct val="114000"/>
+                <a:spcPts val="1937"/>
               </a:lnSpc>
               <a:spcBef>
                 <a:spcPts val="0"/>
@@ -20205,7 +20205,7 @@
           <a:p>
             <a:pPr algn="l">
               <a:lnSpc>
-                <a:spcPct val="114000"/>
+                <a:spcPts val="1937"/>
               </a:lnSpc>
               <a:spcBef>
                 <a:spcPts val="0"/>
@@ -20236,7 +20236,7 @@
           <a:p>
             <a:pPr algn="l">
               <a:lnSpc>
-                <a:spcPct val="114000"/>
+                <a:spcPts val="1937"/>
               </a:lnSpc>
               <a:spcBef>
                 <a:spcPts val="0"/>
@@ -20274,7 +20274,7 @@
         </p:nvSpPr>
         <p:spPr>
           <a:xfrm>
-            <a:off x="594360" y="3759199"/>
+            <a:off x="594360" y="3932428"/>
             <a:ext cx="7955279" cy="777240"/>
           </a:xfrm>
           <a:prstGeom prst="rect">
@@ -32185,7 +32185,7 @@
         <p:spPr>
           <a:xfrm>
             <a:off x="548640" y="1508760"/>
-            <a:ext cx="8046720" cy="2338832"/>
+            <a:ext cx="8046720" cy="2286000"/>
           </a:xfrm>
           <a:prstGeom prst="rect">
             <a:avLst/>
@@ -32213,12 +32213,12 @@
           </a:fontRef>
         </p:style>
         <p:txBody>
-          <a:bodyPr rtlCol="0" anchor="ctr" wrap="none" lIns="152400" rIns="152400" tIns="127000" bIns="127000"/>
+          <a:bodyPr rtlCol="0" anchor="t" wrap="none" lIns="152400" rIns="152400" tIns="92710" bIns="127000"/>
           <a:lstStyle/>
           <a:p>
             <a:pPr algn="l">
               <a:lnSpc>
-                <a:spcPct val="114000"/>
+                <a:spcPts val="2000"/>
               </a:lnSpc>
               <a:spcBef>
                 <a:spcPts val="0"/>
@@ -32249,7 +32249,7 @@
           <a:p>
             <a:pPr algn="l">
               <a:lnSpc>
-                <a:spcPct val="114000"/>
+                <a:spcPts val="2000"/>
               </a:lnSpc>
               <a:spcBef>
                 <a:spcPts val="0"/>
@@ -32280,7 +32280,7 @@
           <a:p>
             <a:pPr algn="l">
               <a:lnSpc>
-                <a:spcPct val="114000"/>
+                <a:spcPts val="2000"/>
               </a:lnSpc>
               <a:spcBef>
                 <a:spcPts val="0"/>
@@ -32311,7 +32311,7 @@
           <a:p>
             <a:pPr algn="l">
               <a:lnSpc>
-                <a:spcPct val="114000"/>
+                <a:spcPts val="2000"/>
               </a:lnSpc>
               <a:spcBef>
                 <a:spcPts val="0"/>
@@ -32342,7 +32342,7 @@
           <a:p>
             <a:pPr algn="l">
               <a:lnSpc>
-                <a:spcPct val="114000"/>
+                <a:spcPts val="2000"/>
               </a:lnSpc>
               <a:spcBef>
                 <a:spcPts val="0"/>
@@ -32367,13 +32367,13 @@
                 <a:ea typeface="Noto Sans CJK JP"/>
                 <a:cs typeface="Liberation Mono"/>
               </a:rPr>
-              <a:t/>
+              <a:t>pred = parse_multi_choice_response(</a:t>
             </a:r>
           </a:p>
           <a:p>
             <a:pPr algn="l">
               <a:lnSpc>
-                <a:spcPct val="114000"/>
+                <a:spcPts val="2000"/>
               </a:lnSpc>
               <a:spcBef>
                 <a:spcPts val="0"/>
@@ -32398,13 +32398,13 @@
                 <a:ea typeface="Noto Sans CJK JP"/>
                 <a:cs typeface="Liberation Mono"/>
               </a:rPr>
-              <a:t>pred = parse_multi_choice_response(</a:t>
+              <a:t>    "Answer: D", choices, index2ans</a:t>
             </a:r>
           </a:p>
           <a:p>
             <a:pPr algn="l">
               <a:lnSpc>
-                <a:spcPct val="114000"/>
+                <a:spcPts val="2000"/>
               </a:lnSpc>
               <a:spcBef>
                 <a:spcPts val="0"/>
@@ -32429,44 +32429,13 @@
                 <a:ea typeface="Noto Sans CJK JP"/>
                 <a:cs typeface="Liberation Mono"/>
               </a:rPr>
-              <a:t>    "Answer: D", choices, index2ans</a:t>
+              <a:t>)</a:t>
             </a:r>
           </a:p>
           <a:p>
             <a:pPr algn="l">
               <a:lnSpc>
-                <a:spcPct val="114000"/>
-              </a:lnSpc>
-              <a:spcBef>
-                <a:spcPts val="0"/>
-              </a:spcBef>
-              <a:spcAft>
-                <a:spcPts val="0"/>
-              </a:spcAft>
-              <a:buNone/>
-              <a:defRPr sz="1600" b="0">
-                <a:solidFill>
-                  <a:srgbClr val="303437"/>
-                </a:solidFill>
-                <a:latin typeface="Noto Sans"/>
-              </a:defRPr>
-            </a:pPr>
-            <a:r>
-              <a:rPr sz="1600" b="0" lang="ja-JP" altLang="en-US">
-                <a:solidFill>
-                  <a:srgbClr val="303437"/>
-                </a:solidFill>
-                <a:latin typeface="Liberation Mono"/>
-                <a:ea typeface="Noto Sans CJK JP"/>
-                <a:cs typeface="Liberation Mono"/>
-              </a:rPr>
-              <a:t>)</a:t>
-            </a:r>
-          </a:p>
-          <a:p>
-            <a:pPr algn="l">
-              <a:lnSpc>
-                <a:spcPct val="114000"/>
+                <a:spcPts val="2000"/>
               </a:lnSpc>
               <a:spcBef>
                 <a:spcPts val="0"/>
@@ -32504,7 +32473,7 @@
         </p:nvSpPr>
         <p:spPr>
           <a:xfrm>
-            <a:off x="594360" y="4048760"/>
+            <a:off x="594360" y="3995928"/>
             <a:ext cx="7955279" cy="777240"/>
           </a:xfrm>
           <a:prstGeom prst="rect">

</xml_diff>

<commit_message>
Proofread mmmu-pro slides page by page with Gemini
</commit_message>
<xml_diff>
--- a/slides/datasets-in-10-minutes-mmmu-pro.pptx
+++ b/slides/datasets-in-10-minutes-mmmu-pro.pptx
@@ -365,7 +365,7 @@
               <c:strCache>
                 <c:ptCount val="4"/>
                 <c:pt idx="0">
-                  <c:v>注釈</c:v>
+                  <c:v>注釈の誤り</c:v>
                 </c:pt>
                 <c:pt idx="1">
                   <c:v>知識不足</c:v>
@@ -9818,7 +9818,7 @@
                 <a:ea typeface="Noto Sans CJK JP"/>
                 <a:cs typeface="Noto Sans"/>
               </a:rPr>
-              <a:t>総合スコアは、Standardの拡張選択肢版とVisionの正解率を平均する。</a:t>
+              <a:t>総合スコアは、Standardの拡張選択肢版とVisionの正解率の平均とする。</a:t>
             </a:r>
           </a:p>
         </p:txBody>
@@ -11007,7 +11007,7 @@
                 <a:ea typeface="Noto Sans CJK JP"/>
                 <a:cs typeface="Noto Sans"/>
               </a:rPr>
-              <a:t>Yueらの同じ1,730問題に対する比較。</a:t>
+              <a:t>Yueらによる同一の1,730問題に対する比較。</a:t>
             </a:r>
           </a:p>
           <a:p>
@@ -11038,7 +11038,7 @@
                 <a:ea typeface="Noto Sans CJK JP"/>
                 <a:cs typeface="Noto Sans"/>
               </a:rPr>
-              <a:t>DirectまたはCoTで、報告された高い方の正解率。</a:t>
+              <a:t>DirectまたはCoTのうち、報告された高い方の正解率。</a:t>
             </a:r>
           </a:p>
         </p:txBody>
@@ -14375,7 +14375,7 @@
                 <a:ea typeface="Noto Sans CJK JP"/>
                 <a:cs typeface="Noto Sans"/>
               </a:rPr>
-              <a:t>YueらがVision形式の誤答60件に付けた分類。横軸は割合（%）。</a:t>
+              <a:t>YueらによるVision形式の誤答60件の分類。横軸は割合（%）。</a:t>
             </a:r>
           </a:p>
         </p:txBody>
@@ -15071,7 +15071,7 @@
                 <a:ea typeface="Noto Sans CJK JP"/>
                 <a:cs typeface="Noto Sans"/>
               </a:rPr>
-              <a:t>残った問題から30科目を各60問、計1,800問抽出し、選択肢の拡張と人手確認へ進む。</a:t>
+              <a:t>残った問題から30科目各60問、計1,800問を抽出し、選択肢の拡張と人手確認へ進む。</a:t>
             </a:r>
           </a:p>
         </p:txBody>
@@ -16674,7 +16674,7 @@
                 <a:ea typeface="Noto Sans CJK JP"/>
                 <a:cs typeface="Noto Sans"/>
               </a:rPr>
-              <a:t>同じ1,730問題に対応する3構成を、test splitで配布する。</a:t>
+              <a:t>同じ1,730問に対応する3構成が、test splitで配布されている。</a:t>
             </a:r>
           </a:p>
         </p:txBody>
@@ -16828,7 +16828,7 @@
                 <a:ea typeface="Noto Sans CJK JP"/>
                 <a:cs typeface="Noto Sans"/>
               </a:rPr>
-              <a:t>工学417問、ほかの5分野は222〜291問</a:t>
+              <a:t>技術・工学417問、ほかの5分野は222〜291問</a:t>
             </a:r>
           </a:p>
         </p:txBody>
@@ -17903,7 +17903,7 @@
                 <a:ea typeface="Noto Sans CJK JP"/>
                 <a:cs typeface="Noto Sans"/>
               </a:rPr>
-              <a:t>問題IDにはtest_やvalidation_で始まるものがある。これは元のMMMUにおける問題IDを引き継いだもの。</a:t>
+              <a:t>問題IDにはtest_やvalidation_で始まるものがある。これは元のMMMUにおける問題IDを引き継いだものである。</a:t>
             </a:r>
           </a:p>
           <a:p>
@@ -19433,7 +19433,7 @@
                           <a:ea typeface="Noto Sans CJK JP"/>
                           <a:cs typeface="Noto Sans"/>
                         </a:rPr>
-                        <a:t>画像内ラベルとシャッフル後の選択肢を対応</a:t>
+                        <a:t>画像内ラベルとシャッフル後の選択肢を対応付け</a:t>
                       </a:r>
                     </a:p>
                   </a:txBody>
@@ -20867,7 +20867,7 @@
                 <a:ea typeface="Noto Sans CJK JP"/>
                 <a:cs typeface="Noto Sans"/>
               </a:rPr>
-              <a:t>図の構造や表の数値を読み、知識・計算と結び付けて、正しい選択肢を答える。</a:t>
+              <a:t>図の構造や表の数値を読み、知識・計算と結び付けて、正しい選択肢を選ぶ。</a:t>
             </a:r>
           </a:p>
           <a:p>
@@ -21842,7 +21842,7 @@
                 <a:ea typeface="Noto Sans CJK JP"/>
                 <a:cs typeface="Noto Sans"/>
               </a:rPr>
-              <a:t>被写体が比較的はっきりし、背景が横方向に流れている写真を選ぶ。</a:t>
+              <a:t>解説：被写体が比較的はっきりし、背景が横方向に流れている写真を選ぶ。</a:t>
             </a:r>
           </a:p>
         </p:txBody>
@@ -23237,7 +23237,7 @@
                 <a:ea typeface="Noto Sans CJK JP"/>
                 <a:cs typeface="Noto Sans"/>
               </a:rPr>
-              <a:t>正解 C：体節・対称性</a:t>
+              <a:t>正解 C：体節・対称性・</a:t>
             </a:r>
           </a:p>
           <a:p>
@@ -23713,7 +23713,7 @@
                 <a:ea typeface="Noto Sans CJK JP"/>
                 <a:cs typeface="Noto Sans"/>
               </a:rPr>
-              <a:t>正解 B：ダチョウの写真</a:t>
+              <a:t>正解 B：レアの写真</a:t>
             </a:r>
           </a:p>
         </p:txBody>
@@ -24657,7 +24657,7 @@
                 <a:ea typeface="Noto Sans CJK JP"/>
                 <a:cs typeface="Noto Sans"/>
               </a:rPr>
-              <a:t>図の位置を、右心室と肺動脈の間にある弁へ対応させる。</a:t>
+              <a:t>図の位置を、右心室と肺動脈の間にある弁に対応させる。</a:t>
             </a:r>
           </a:p>
         </p:txBody>
@@ -26346,7 +26346,7 @@
                 <a:ea typeface="Noto Sans CJK JP"/>
                 <a:cs typeface="Noto Sans"/>
               </a:rPr>
-              <a:t>画像の値・位置・構造を読み、科目ごとの知識や計算と結び付けて、正しい選択肢を答える。</a:t>
+              <a:t>画像の値・位置・構造を読み、科目ごとの知識や計算と結び付けて、正しい選択肢を選ぶ。</a:t>
             </a:r>
           </a:p>
           <a:p>
@@ -26376,7 +26376,7 @@
                 <a:ea typeface="Noto Sans CJK JP"/>
                 <a:cs typeface="Noto Sans"/>
               </a:rPr>
-              <a:t>30科目の1,730問題を、文章と画像を分けた形式と、問題文も画像に収めた形式で評価する。</a:t>
+              <a:t>30科目の1,730問を、文章と画像を分けた形式と、問題文も画像に収めた形式で評価する。</a:t>
             </a:r>
           </a:p>
         </p:txBody>
@@ -34800,7 +34800,7 @@
                 <a:ea typeface="Noto Sans CJK JP"/>
                 <a:cs typeface="Noto Sans"/>
               </a:rPr>
-              <a:t>先行するMMMUはYueらがCVPR 2024で発表し、MMMU-ProはACL 2025で発表した。</a:t>
+              <a:t>先行するMMMUはYueらがCVPR 2024で発表し、MMMU-ProはACL 2025で発表された。</a:t>
             </a:r>
           </a:p>
           <a:p>
@@ -35196,7 +35196,7 @@
                 <a:ea typeface="Noto Sans CJK JP"/>
                 <a:cs typeface="Noto Sans"/>
               </a:rPr>
-              <a:t>画像なしで解ける問題の除外、選択肢拡張、Vision形式と、それぞれの評価を報告する。</a:t>
+              <a:t>画像なしで解ける問題の除外、選択肢拡張、Vision形式、およびそれぞれの評価を報告する。</a:t>
             </a:r>
           </a:p>
           <a:p>

</xml_diff>

<commit_message>
Improve mmmu-pro answer visibility and citation wording
</commit_message>
<xml_diff>
--- a/slides/datasets-in-10-minutes-mmmu-pro.pptx
+++ b/slides/datasets-in-10-minutes-mmmu-pro.pptx
@@ -8131,7 +8131,7 @@
         <p:spPr>
           <a:xfrm>
             <a:off x="4864608" y="2948940"/>
-            <a:ext cx="3703320" cy="377952"/>
+            <a:ext cx="3703320" cy="386794"/>
           </a:xfrm>
           <a:prstGeom prst="rect">
             <a:avLst/>
@@ -8146,7 +8146,7 @@
           <a:p>
             <a:pPr algn="l">
               <a:lnSpc>
-                <a:spcPct val="120000"/>
+                <a:spcPts val="2640"/>
               </a:lnSpc>
               <a:spcBef>
                 <a:spcPts val="0"/>
@@ -8163,9 +8163,9 @@
               </a:defRPr>
             </a:pPr>
             <a:r>
-              <a:rPr sz="2000" b="1" lang="ja-JP" altLang="en-US">
-                <a:solidFill>
-                  <a:srgbClr val="B13731"/>
+              <a:rPr sz="2200" b="1" lang="ja-JP" altLang="en-US">
+                <a:solidFill>
+                  <a:schemeClr val="accent1"/>
                 </a:solidFill>
                 <a:latin typeface="Noto Sans"/>
                 <a:ea typeface="Noto Sans CJK JP"/>
@@ -8894,7 +8894,7 @@
         <p:spPr>
           <a:xfrm>
             <a:off x="4864608" y="2948940"/>
-            <a:ext cx="3703320" cy="377952"/>
+            <a:ext cx="3703320" cy="386794"/>
           </a:xfrm>
           <a:prstGeom prst="rect">
             <a:avLst/>
@@ -8909,7 +8909,7 @@
           <a:p>
             <a:pPr algn="l">
               <a:lnSpc>
-                <a:spcPct val="120000"/>
+                <a:spcPts val="2640"/>
               </a:lnSpc>
               <a:spcBef>
                 <a:spcPts val="0"/>
@@ -8926,9 +8926,9 @@
               </a:defRPr>
             </a:pPr>
             <a:r>
-              <a:rPr sz="2000" b="1" lang="ja-JP" altLang="en-US">
-                <a:solidFill>
-                  <a:srgbClr val="B13731"/>
+              <a:rPr sz="2200" b="1" lang="ja-JP" altLang="en-US">
+                <a:solidFill>
+                  <a:schemeClr val="accent1"/>
                 </a:solidFill>
                 <a:latin typeface="Noto Sans"/>
                 <a:ea typeface="Noto Sans CJK JP"/>
@@ -21713,7 +21713,7 @@
         <p:spPr>
           <a:xfrm>
             <a:off x="4864608" y="2948940"/>
-            <a:ext cx="3703320" cy="377952"/>
+            <a:ext cx="3703320" cy="386794"/>
           </a:xfrm>
           <a:prstGeom prst="rect">
             <a:avLst/>
@@ -21728,7 +21728,7 @@
           <a:p>
             <a:pPr algn="l">
               <a:lnSpc>
-                <a:spcPct val="120000"/>
+                <a:spcPts val="2640"/>
               </a:lnSpc>
               <a:spcBef>
                 <a:spcPts val="0"/>
@@ -21745,9 +21745,9 @@
               </a:defRPr>
             </a:pPr>
             <a:r>
-              <a:rPr sz="2000" b="1" lang="ja-JP" altLang="en-US">
-                <a:solidFill>
-                  <a:srgbClr val="B13731"/>
+              <a:rPr sz="2200" b="1" lang="ja-JP" altLang="en-US">
+                <a:solidFill>
+                  <a:schemeClr val="accent1"/>
                 </a:solidFill>
                 <a:latin typeface="Noto Sans"/>
                 <a:ea typeface="Noto Sans CJK JP"/>
@@ -22272,7 +22272,7 @@
         <p:spPr>
           <a:xfrm>
             <a:off x="4864608" y="2651760"/>
-            <a:ext cx="3703320" cy="377952"/>
+            <a:ext cx="3703320" cy="758952"/>
           </a:xfrm>
           <a:prstGeom prst="rect">
             <a:avLst/>
@@ -22287,7 +22287,7 @@
           <a:p>
             <a:pPr algn="l">
               <a:lnSpc>
-                <a:spcPct val="120000"/>
+                <a:spcPts val="2640"/>
               </a:lnSpc>
               <a:spcBef>
                 <a:spcPts val="0"/>
@@ -22304,9 +22304,9 @@
               </a:defRPr>
             </a:pPr>
             <a:r>
-              <a:rPr sz="2000" b="1" lang="ja-JP" altLang="en-US">
-                <a:solidFill>
-                  <a:srgbClr val="B13731"/>
+              <a:rPr sz="2200" b="1" lang="ja-JP" altLang="en-US">
+                <a:solidFill>
+                  <a:schemeClr val="accent1"/>
                 </a:solidFill>
                 <a:latin typeface="Noto Sans"/>
                 <a:ea typeface="Noto Sans CJK JP"/>
@@ -22325,7 +22325,7 @@
         </p:nvSpPr>
         <p:spPr>
           <a:xfrm>
-            <a:off x="4864608" y="3194304"/>
+            <a:off x="4864608" y="3502152"/>
             <a:ext cx="3703320" cy="1377696"/>
           </a:xfrm>
           <a:prstGeom prst="rect">
@@ -22717,7 +22717,7 @@
         <p:spPr>
           <a:xfrm>
             <a:off x="4864608" y="2651760"/>
-            <a:ext cx="3703320" cy="377952"/>
+            <a:ext cx="3703320" cy="386616"/>
           </a:xfrm>
           <a:prstGeom prst="rect">
             <a:avLst/>
@@ -22732,7 +22732,7 @@
           <a:p>
             <a:pPr algn="l">
               <a:lnSpc>
-                <a:spcPct val="120000"/>
+                <a:spcPts val="2640"/>
               </a:lnSpc>
               <a:spcBef>
                 <a:spcPts val="0"/>
@@ -22749,9 +22749,9 @@
               </a:defRPr>
             </a:pPr>
             <a:r>
-              <a:rPr sz="2000" b="1" lang="ja-JP" altLang="en-US">
-                <a:solidFill>
-                  <a:srgbClr val="B13731"/>
+              <a:rPr sz="2200" b="1" lang="ja-JP" altLang="en-US">
+                <a:solidFill>
+                  <a:schemeClr val="accent1"/>
                 </a:solidFill>
                 <a:latin typeface="Noto Sans"/>
                 <a:ea typeface="Noto Sans CJK JP"/>
@@ -23162,7 +23162,7 @@
         <p:spPr>
           <a:xfrm>
             <a:off x="4864608" y="2948940"/>
-            <a:ext cx="3703320" cy="682751"/>
+            <a:ext cx="3703320" cy="720563"/>
           </a:xfrm>
           <a:prstGeom prst="rect">
             <a:avLst/>
@@ -23177,7 +23177,7 @@
           <a:p>
             <a:pPr algn="l">
               <a:lnSpc>
-                <a:spcPct val="120000"/>
+                <a:spcPts val="2640"/>
               </a:lnSpc>
               <a:spcBef>
                 <a:spcPts val="0"/>
@@ -23194,9 +23194,9 @@
               </a:defRPr>
             </a:pPr>
             <a:r>
-              <a:rPr sz="2000" b="1" lang="ja-JP" altLang="en-US">
-                <a:solidFill>
-                  <a:srgbClr val="B13731"/>
+              <a:rPr sz="2200" b="1" lang="ja-JP" altLang="en-US">
+                <a:solidFill>
+                  <a:schemeClr val="accent1"/>
                 </a:solidFill>
                 <a:latin typeface="Noto Sans"/>
                 <a:ea typeface="Noto Sans CJK JP"/>
@@ -23208,7 +23208,7 @@
           <a:p>
             <a:pPr algn="l">
               <a:lnSpc>
-                <a:spcPct val="120000"/>
+                <a:spcPts val="2640"/>
               </a:lnSpc>
               <a:spcBef>
                 <a:spcPts val="0"/>
@@ -23225,9 +23225,9 @@
               </a:defRPr>
             </a:pPr>
             <a:r>
-              <a:rPr sz="2000" b="1" lang="ja-JP" altLang="en-US">
-                <a:solidFill>
-                  <a:srgbClr val="B13731"/>
+              <a:rPr sz="2200" b="1" lang="ja-JP" altLang="en-US">
+                <a:solidFill>
+                  <a:schemeClr val="accent1"/>
                 </a:solidFill>
                 <a:latin typeface="Noto Sans"/>
                 <a:ea typeface="Noto Sans CJK JP"/>
@@ -23638,7 +23638,7 @@
         <p:spPr>
           <a:xfrm>
             <a:off x="4864608" y="2651760"/>
-            <a:ext cx="3703320" cy="377952"/>
+            <a:ext cx="3703320" cy="386616"/>
           </a:xfrm>
           <a:prstGeom prst="rect">
             <a:avLst/>
@@ -23653,7 +23653,7 @@
           <a:p>
             <a:pPr algn="l">
               <a:lnSpc>
-                <a:spcPct val="120000"/>
+                <a:spcPts val="2640"/>
               </a:lnSpc>
               <a:spcBef>
                 <a:spcPts val="0"/>
@@ -23670,9 +23670,9 @@
               </a:defRPr>
             </a:pPr>
             <a:r>
-              <a:rPr sz="2000" b="1" lang="ja-JP" altLang="en-US">
-                <a:solidFill>
-                  <a:srgbClr val="B13731"/>
+              <a:rPr sz="2200" b="1" lang="ja-JP" altLang="en-US">
+                <a:solidFill>
+                  <a:schemeClr val="accent1"/>
                 </a:solidFill>
                 <a:latin typeface="Noto Sans"/>
                 <a:ea typeface="Noto Sans CJK JP"/>
@@ -24083,7 +24083,7 @@
         <p:spPr>
           <a:xfrm>
             <a:off x="4864608" y="2948940"/>
-            <a:ext cx="3703320" cy="377952"/>
+            <a:ext cx="3703320" cy="386794"/>
           </a:xfrm>
           <a:prstGeom prst="rect">
             <a:avLst/>
@@ -24098,7 +24098,7 @@
           <a:p>
             <a:pPr algn="l">
               <a:lnSpc>
-                <a:spcPct val="120000"/>
+                <a:spcPts val="2640"/>
               </a:lnSpc>
               <a:spcBef>
                 <a:spcPts val="0"/>
@@ -24115,9 +24115,9 @@
               </a:defRPr>
             </a:pPr>
             <a:r>
-              <a:rPr sz="2000" b="1" lang="ja-JP" altLang="en-US">
-                <a:solidFill>
-                  <a:srgbClr val="B13731"/>
+              <a:rPr sz="2200" b="1" lang="ja-JP" altLang="en-US">
+                <a:solidFill>
+                  <a:schemeClr val="accent1"/>
                 </a:solidFill>
                 <a:latin typeface="Noto Sans"/>
                 <a:ea typeface="Noto Sans CJK JP"/>
@@ -24528,7 +24528,7 @@
         <p:spPr>
           <a:xfrm>
             <a:off x="4864608" y="2651760"/>
-            <a:ext cx="3703320" cy="377952"/>
+            <a:ext cx="3703320" cy="386616"/>
           </a:xfrm>
           <a:prstGeom prst="rect">
             <a:avLst/>
@@ -24543,7 +24543,7 @@
           <a:p>
             <a:pPr algn="l">
               <a:lnSpc>
-                <a:spcPct val="120000"/>
+                <a:spcPts val="2640"/>
               </a:lnSpc>
               <a:spcBef>
                 <a:spcPts val="0"/>
@@ -24560,9 +24560,9 @@
               </a:defRPr>
             </a:pPr>
             <a:r>
-              <a:rPr sz="2000" b="1" lang="ja-JP" altLang="en-US">
-                <a:solidFill>
-                  <a:srgbClr val="B13731"/>
+              <a:rPr sz="2200" b="1" lang="ja-JP" altLang="en-US">
+                <a:solidFill>
+                  <a:schemeClr val="accent1"/>
                 </a:solidFill>
                 <a:latin typeface="Noto Sans"/>
                 <a:ea typeface="Noto Sans CJK JP"/>
@@ -24973,7 +24973,7 @@
         <p:spPr>
           <a:xfrm>
             <a:off x="4864608" y="2948940"/>
-            <a:ext cx="3703320" cy="377952"/>
+            <a:ext cx="3703320" cy="758952"/>
           </a:xfrm>
           <a:prstGeom prst="rect">
             <a:avLst/>
@@ -24988,7 +24988,7 @@
           <a:p>
             <a:pPr algn="l">
               <a:lnSpc>
-                <a:spcPct val="120000"/>
+                <a:spcPts val="2640"/>
               </a:lnSpc>
               <a:spcBef>
                 <a:spcPts val="0"/>
@@ -25005,9 +25005,9 @@
               </a:defRPr>
             </a:pPr>
             <a:r>
-              <a:rPr sz="2000" b="1" lang="ja-JP" altLang="en-US">
-                <a:solidFill>
-                  <a:srgbClr val="B13731"/>
+              <a:rPr sz="2200" b="1" lang="ja-JP" altLang="en-US">
+                <a:solidFill>
+                  <a:schemeClr val="accent1"/>
                 </a:solidFill>
                 <a:latin typeface="Noto Sans"/>
                 <a:ea typeface="Noto Sans CJK JP"/>
@@ -25026,7 +25026,7 @@
         </p:nvSpPr>
         <p:spPr>
           <a:xfrm>
-            <a:off x="4864608" y="3491484"/>
+            <a:off x="4864608" y="3799332"/>
             <a:ext cx="3703320" cy="1080516"/>
           </a:xfrm>
           <a:prstGeom prst="rect">
@@ -25418,7 +25418,7 @@
         <p:spPr>
           <a:xfrm>
             <a:off x="4864608" y="2651760"/>
-            <a:ext cx="3703320" cy="377952"/>
+            <a:ext cx="3703320" cy="386616"/>
           </a:xfrm>
           <a:prstGeom prst="rect">
             <a:avLst/>
@@ -25433,7 +25433,7 @@
           <a:p>
             <a:pPr algn="l">
               <a:lnSpc>
-                <a:spcPct val="120000"/>
+                <a:spcPts val="2640"/>
               </a:lnSpc>
               <a:spcBef>
                 <a:spcPts val="0"/>
@@ -25450,9 +25450,9 @@
               </a:defRPr>
             </a:pPr>
             <a:r>
-              <a:rPr sz="2000" b="1" lang="ja-JP" altLang="en-US">
-                <a:solidFill>
-                  <a:srgbClr val="B13731"/>
+              <a:rPr sz="2200" b="1" lang="ja-JP" altLang="en-US">
+                <a:solidFill>
+                  <a:schemeClr val="accent1"/>
                 </a:solidFill>
                 <a:latin typeface="Noto Sans"/>
                 <a:ea typeface="Noto Sans CJK JP"/>
@@ -25863,7 +25863,7 @@
         <p:spPr>
           <a:xfrm>
             <a:off x="4864608" y="3246120"/>
-            <a:ext cx="3703320" cy="377952"/>
+            <a:ext cx="3703320" cy="386617"/>
           </a:xfrm>
           <a:prstGeom prst="rect">
             <a:avLst/>
@@ -25878,7 +25878,7 @@
           <a:p>
             <a:pPr algn="l">
               <a:lnSpc>
-                <a:spcPct val="120000"/>
+                <a:spcPts val="2640"/>
               </a:lnSpc>
               <a:spcBef>
                 <a:spcPts val="0"/>
@@ -25895,9 +25895,9 @@
               </a:defRPr>
             </a:pPr>
             <a:r>
-              <a:rPr sz="2000" b="1" lang="ja-JP" altLang="en-US">
-                <a:solidFill>
-                  <a:srgbClr val="B13731"/>
+              <a:rPr sz="2200" b="1" lang="ja-JP" altLang="en-US">
+                <a:solidFill>
+                  <a:schemeClr val="accent1"/>
                 </a:solidFill>
                 <a:latin typeface="Noto Sans"/>
                 <a:ea typeface="Noto Sans CJK JP"/>
@@ -36702,7 +36702,7 @@
         <p:spPr>
           <a:xfrm>
             <a:off x="4864608" y="3246120"/>
-            <a:ext cx="3703320" cy="377952"/>
+            <a:ext cx="3703320" cy="386617"/>
           </a:xfrm>
           <a:prstGeom prst="rect">
             <a:avLst/>
@@ -36717,7 +36717,7 @@
           <a:p>
             <a:pPr algn="l">
               <a:lnSpc>
-                <a:spcPct val="120000"/>
+                <a:spcPts val="2640"/>
               </a:lnSpc>
               <a:spcBef>
                 <a:spcPts val="0"/>
@@ -36734,9 +36734,9 @@
               </a:defRPr>
             </a:pPr>
             <a:r>
-              <a:rPr sz="2000" b="1" lang="ja-JP" altLang="en-US">
-                <a:solidFill>
-                  <a:srgbClr val="B13731"/>
+              <a:rPr sz="2200" b="1" lang="ja-JP" altLang="en-US">
+                <a:solidFill>
+                  <a:schemeClr val="accent1"/>
                 </a:solidFill>
                 <a:latin typeface="Noto Sans"/>
                 <a:ea typeface="Noto Sans CJK JP"/>

</xml_diff>